<commit_message>
Slide deck v3: dollar-quantified problem, architecture diagram, guardrail stat tiles, key takeaways
- Problem slide: $31.7B FY2024 Medicare FFS improper payments (CMS) alongside the ~80% stat
- POC slide: architecture diagram embedded
- Guardrails slide: stat tiles (74,719 / 97.8% / 92.1%) + code-set drift finding
- New Key Takeaways slide; 11 -> 12 slides
</commit_message>
<xml_diff>
--- a/deliverables/slides.pptx
+++ b/deliverables/slides.pptx
@@ -16,6 +16,7 @@
     <p:sldId id="264" r:id="rId15"/>
     <p:sldId id="265" r:id="rId16"/>
     <p:sldId id="266" r:id="rId17"/>
+    <p:sldId id="267" r:id="rId18"/>
   </p:sldIdLst>
   <p:sldSz cx="12191695" cy="6858000" type="screen4x3"/>
   <p:notesSz cx="6858000" cy="9144000"/>
@@ -3435,6 +3436,518 @@
     <p:bg>
       <p:bgPr>
         <a:solidFill>
+          <a:srgbClr val="FFFFFF"/>
+        </a:solidFill>
+        <a:effectLst/>
+      </p:bgPr>
+    </p:bg>
+    <p:spTree>
+      <p:nvGrpSpPr>
+        <p:cNvPr id="1" name=""/>
+        <p:cNvGrpSpPr/>
+        <p:nvPr/>
+      </p:nvGrpSpPr>
+      <p:grpSpPr/>
+      <p:sp>
+        <p:nvSpPr>
+          <p:cNvPr id="2" name="Rectangle 1"/>
+          <p:cNvSpPr/>
+          <p:nvPr/>
+        </p:nvSpPr>
+        <p:spPr>
+          <a:xfrm>
+            <a:off x="0" y="0"/>
+            <a:ext cx="12191695" cy="1051560"/>
+          </a:xfrm>
+          <a:prstGeom prst="rect">
+            <a:avLst/>
+          </a:prstGeom>
+          <a:solidFill>
+            <a:srgbClr val="0E4D52"/>
+          </a:solidFill>
+          <a:ln>
+            <a:noFill/>
+          </a:ln>
+        </p:spPr>
+        <p:style>
+          <a:lnRef idx="1">
+            <a:schemeClr val="accent1"/>
+          </a:lnRef>
+          <a:fillRef idx="3">
+            <a:schemeClr val="accent1"/>
+          </a:fillRef>
+          <a:effectRef idx="2">
+            <a:schemeClr val="accent1"/>
+          </a:effectRef>
+          <a:fontRef idx="minor">
+            <a:schemeClr val="lt1"/>
+          </a:fontRef>
+        </p:style>
+        <p:txBody>
+          <a:bodyPr rtlCol="0" anchor="ctr" lIns="548640"/>
+          <a:lstStyle/>
+          <a:p>
+            <a:pPr algn="ctr"/>
+            <a:r>
+              <a:rPr sz="3000" b="1">
+                <a:solidFill>
+                  <a:srgbClr val="FFFFFF"/>
+                </a:solidFill>
+              </a:rPr>
+              <a:t>Key Takeaways</a:t>
+            </a:r>
+          </a:p>
+        </p:txBody>
+      </p:sp>
+      <p:sp>
+        <p:nvSpPr>
+          <p:cNvPr id="3" name="Rectangle 2"/>
+          <p:cNvSpPr/>
+          <p:nvPr/>
+        </p:nvSpPr>
+        <p:spPr>
+          <a:xfrm>
+            <a:off x="731520" y="1737360"/>
+            <a:ext cx="502920" cy="502920"/>
+          </a:xfrm>
+          <a:prstGeom prst="rect">
+            <a:avLst/>
+          </a:prstGeom>
+          <a:solidFill>
+            <a:srgbClr val="0E4D52"/>
+          </a:solidFill>
+          <a:ln>
+            <a:noFill/>
+          </a:ln>
+        </p:spPr>
+        <p:style>
+          <a:lnRef idx="1">
+            <a:schemeClr val="accent1"/>
+          </a:lnRef>
+          <a:fillRef idx="3">
+            <a:schemeClr val="accent1"/>
+          </a:fillRef>
+          <a:effectRef idx="2">
+            <a:schemeClr val="accent1"/>
+          </a:effectRef>
+          <a:fontRef idx="minor">
+            <a:schemeClr val="lt1"/>
+          </a:fontRef>
+        </p:style>
+        <p:txBody>
+          <a:bodyPr rtlCol="0" anchor="ctr"/>
+          <a:lstStyle/>
+          <a:p>
+            <a:pPr algn="ctr"/>
+          </a:p>
+        </p:txBody>
+      </p:sp>
+      <p:sp>
+        <p:nvSpPr>
+          <p:cNvPr id="4" name="TextBox 3"/>
+          <p:cNvSpPr txBox="1"/>
+          <p:nvPr/>
+        </p:nvSpPr>
+        <p:spPr>
+          <a:xfrm>
+            <a:off x="731520" y="1792224"/>
+            <a:ext cx="502920" cy="411480"/>
+          </a:xfrm>
+          <a:prstGeom prst="rect">
+            <a:avLst/>
+          </a:prstGeom>
+          <a:noFill/>
+        </p:spPr>
+        <p:txBody>
+          <a:bodyPr wrap="square">
+            <a:spAutoFit/>
+          </a:bodyPr>
+          <a:lstStyle/>
+          <a:p>
+            <a:pPr algn="ctr"/>
+            <a:r>
+              <a:rPr sz="2200" b="1">
+                <a:solidFill>
+                  <a:srgbClr val="FFFFFF"/>
+                </a:solidFill>
+              </a:rPr>
+              <a:t>1</a:t>
+            </a:r>
+          </a:p>
+        </p:txBody>
+      </p:sp>
+      <p:sp>
+        <p:nvSpPr>
+          <p:cNvPr id="5" name="TextBox 4"/>
+          <p:cNvSpPr txBox="1"/>
+          <p:nvPr/>
+        </p:nvSpPr>
+        <p:spPr>
+          <a:xfrm>
+            <a:off x="1463040" y="1691640"/>
+            <a:ext cx="10058400" cy="457200"/>
+          </a:xfrm>
+          <a:prstGeom prst="rect">
+            <a:avLst/>
+          </a:prstGeom>
+          <a:noFill/>
+        </p:spPr>
+        <p:txBody>
+          <a:bodyPr wrap="square">
+            <a:spAutoFit/>
+          </a:bodyPr>
+          <a:lstStyle/>
+          <a:p>
+            <a:pPr algn="l"/>
+            <a:r>
+              <a:rPr sz="2100" b="1">
+                <a:solidFill>
+                  <a:srgbClr val="202020"/>
+                </a:solidFill>
+              </a:rPr>
+              <a:t>The eras separate on judgment, not detection</a:t>
+            </a:r>
+          </a:p>
+        </p:txBody>
+      </p:sp>
+      <p:sp>
+        <p:nvSpPr>
+          <p:cNvPr id="6" name="TextBox 5"/>
+          <p:cNvSpPr txBox="1"/>
+          <p:nvPr/>
+        </p:nvSpPr>
+        <p:spPr>
+          <a:xfrm>
+            <a:off x="1463040" y="2176272"/>
+            <a:ext cx="10058400" cy="822960"/>
+          </a:xfrm>
+          <a:prstGeom prst="rect">
+            <a:avLst/>
+          </a:prstGeom>
+          <a:noFill/>
+        </p:spPr>
+        <p:txBody>
+          <a:bodyPr wrap="square">
+            <a:spAutoFit/>
+          </a:bodyPr>
+          <a:lstStyle/>
+          <a:p>
+            <a:pPr algn="l"/>
+            <a:r>
+              <a:rPr sz="1600" b="0">
+                <a:solidFill>
+                  <a:srgbClr val="555555"/>
+                </a:solidFill>
+              </a:rPr>
+              <a:t>Status accuracy 89% → 100%; on real notes the dictionary missed the discharge diagnosis itself.</a:t>
+            </a:r>
+          </a:p>
+        </p:txBody>
+      </p:sp>
+      <p:sp>
+        <p:nvSpPr>
+          <p:cNvPr id="7" name="Rectangle 6"/>
+          <p:cNvSpPr/>
+          <p:nvPr/>
+        </p:nvSpPr>
+        <p:spPr>
+          <a:xfrm>
+            <a:off x="731520" y="3246120"/>
+            <a:ext cx="502920" cy="502920"/>
+          </a:xfrm>
+          <a:prstGeom prst="rect">
+            <a:avLst/>
+          </a:prstGeom>
+          <a:solidFill>
+            <a:srgbClr val="0E4D52"/>
+          </a:solidFill>
+          <a:ln>
+            <a:noFill/>
+          </a:ln>
+        </p:spPr>
+        <p:style>
+          <a:lnRef idx="1">
+            <a:schemeClr val="accent1"/>
+          </a:lnRef>
+          <a:fillRef idx="3">
+            <a:schemeClr val="accent1"/>
+          </a:fillRef>
+          <a:effectRef idx="2">
+            <a:schemeClr val="accent1"/>
+          </a:effectRef>
+          <a:fontRef idx="minor">
+            <a:schemeClr val="lt1"/>
+          </a:fontRef>
+        </p:style>
+        <p:txBody>
+          <a:bodyPr rtlCol="0" anchor="ctr"/>
+          <a:lstStyle/>
+          <a:p>
+            <a:pPr algn="ctr"/>
+          </a:p>
+        </p:txBody>
+      </p:sp>
+      <p:sp>
+        <p:nvSpPr>
+          <p:cNvPr id="8" name="TextBox 7"/>
+          <p:cNvSpPr txBox="1"/>
+          <p:nvPr/>
+        </p:nvSpPr>
+        <p:spPr>
+          <a:xfrm>
+            <a:off x="731520" y="3300984"/>
+            <a:ext cx="502920" cy="411480"/>
+          </a:xfrm>
+          <a:prstGeom prst="rect">
+            <a:avLst/>
+          </a:prstGeom>
+          <a:noFill/>
+        </p:spPr>
+        <p:txBody>
+          <a:bodyPr wrap="square">
+            <a:spAutoFit/>
+          </a:bodyPr>
+          <a:lstStyle/>
+          <a:p>
+            <a:pPr algn="ctr"/>
+            <a:r>
+              <a:rPr sz="2200" b="1">
+                <a:solidFill>
+                  <a:srgbClr val="FFFFFF"/>
+                </a:solidFill>
+              </a:rPr>
+              <a:t>2</a:t>
+            </a:r>
+          </a:p>
+        </p:txBody>
+      </p:sp>
+      <p:sp>
+        <p:nvSpPr>
+          <p:cNvPr id="9" name="TextBox 8"/>
+          <p:cNvSpPr txBox="1"/>
+          <p:nvPr/>
+        </p:nvSpPr>
+        <p:spPr>
+          <a:xfrm>
+            <a:off x="1463040" y="3200400"/>
+            <a:ext cx="10058400" cy="457200"/>
+          </a:xfrm>
+          <a:prstGeom prst="rect">
+            <a:avLst/>
+          </a:prstGeom>
+          <a:noFill/>
+        </p:spPr>
+        <p:txBody>
+          <a:bodyPr wrap="square">
+            <a:spAutoFit/>
+          </a:bodyPr>
+          <a:lstStyle/>
+          <a:p>
+            <a:pPr algn="l"/>
+            <a:r>
+              <a:rPr sz="2100" b="1">
+                <a:solidFill>
+                  <a:srgbClr val="202020"/>
+                </a:solidFill>
+              </a:rPr>
+              <a:t>Trust is an architecture, not a model property</a:t>
+            </a:r>
+          </a:p>
+        </p:txBody>
+      </p:sp>
+      <p:sp>
+        <p:nvSpPr>
+          <p:cNvPr id="10" name="TextBox 9"/>
+          <p:cNvSpPr txBox="1"/>
+          <p:nvPr/>
+        </p:nvSpPr>
+        <p:spPr>
+          <a:xfrm>
+            <a:off x="1463040" y="3685032"/>
+            <a:ext cx="10058400" cy="822960"/>
+          </a:xfrm>
+          <a:prstGeom prst="rect">
+            <a:avLst/>
+          </a:prstGeom>
+          <a:noFill/>
+        </p:spPr>
+        <p:txBody>
+          <a:bodyPr wrap="square">
+            <a:spAutoFit/>
+          </a:bodyPr>
+          <a:lstStyle/>
+          <a:p>
+            <a:pPr algn="l"/>
+            <a:r>
+              <a:rPr sz="1600" b="0">
+                <a:solidFill>
+                  <a:srgbClr val="555555"/>
+                </a:solidFill>
+              </a:rPr>
+              <a:t>Official code-table validation + evidence spans + audit artifacts make LLM output defensible.</a:t>
+            </a:r>
+          </a:p>
+        </p:txBody>
+      </p:sp>
+      <p:sp>
+        <p:nvSpPr>
+          <p:cNvPr id="11" name="Rectangle 10"/>
+          <p:cNvSpPr/>
+          <p:nvPr/>
+        </p:nvSpPr>
+        <p:spPr>
+          <a:xfrm>
+            <a:off x="731520" y="4754879"/>
+            <a:ext cx="502920" cy="502920"/>
+          </a:xfrm>
+          <a:prstGeom prst="rect">
+            <a:avLst/>
+          </a:prstGeom>
+          <a:solidFill>
+            <a:srgbClr val="0E4D52"/>
+          </a:solidFill>
+          <a:ln>
+            <a:noFill/>
+          </a:ln>
+        </p:spPr>
+        <p:style>
+          <a:lnRef idx="1">
+            <a:schemeClr val="accent1"/>
+          </a:lnRef>
+          <a:fillRef idx="3">
+            <a:schemeClr val="accent1"/>
+          </a:fillRef>
+          <a:effectRef idx="2">
+            <a:schemeClr val="accent1"/>
+          </a:effectRef>
+          <a:fontRef idx="minor">
+            <a:schemeClr val="lt1"/>
+          </a:fontRef>
+        </p:style>
+        <p:txBody>
+          <a:bodyPr rtlCol="0" anchor="ctr"/>
+          <a:lstStyle/>
+          <a:p>
+            <a:pPr algn="ctr"/>
+          </a:p>
+        </p:txBody>
+      </p:sp>
+      <p:sp>
+        <p:nvSpPr>
+          <p:cNvPr id="12" name="TextBox 11"/>
+          <p:cNvSpPr txBox="1"/>
+          <p:nvPr/>
+        </p:nvSpPr>
+        <p:spPr>
+          <a:xfrm>
+            <a:off x="731520" y="4809743"/>
+            <a:ext cx="502920" cy="411480"/>
+          </a:xfrm>
+          <a:prstGeom prst="rect">
+            <a:avLst/>
+          </a:prstGeom>
+          <a:noFill/>
+        </p:spPr>
+        <p:txBody>
+          <a:bodyPr wrap="square">
+            <a:spAutoFit/>
+          </a:bodyPr>
+          <a:lstStyle/>
+          <a:p>
+            <a:pPr algn="ctr"/>
+            <a:r>
+              <a:rPr sz="2200" b="1">
+                <a:solidFill>
+                  <a:srgbClr val="FFFFFF"/>
+                </a:solidFill>
+              </a:rPr>
+              <a:t>3</a:t>
+            </a:r>
+          </a:p>
+        </p:txBody>
+      </p:sp>
+      <p:sp>
+        <p:nvSpPr>
+          <p:cNvPr id="13" name="TextBox 12"/>
+          <p:cNvSpPr txBox="1"/>
+          <p:nvPr/>
+        </p:nvSpPr>
+        <p:spPr>
+          <a:xfrm>
+            <a:off x="1463040" y="4709159"/>
+            <a:ext cx="10058400" cy="457200"/>
+          </a:xfrm>
+          <a:prstGeom prst="rect">
+            <a:avLst/>
+          </a:prstGeom>
+          <a:noFill/>
+        </p:spPr>
+        <p:txBody>
+          <a:bodyPr wrap="square">
+            <a:spAutoFit/>
+          </a:bodyPr>
+          <a:lstStyle/>
+          <a:p>
+            <a:pPr algn="l"/>
+            <a:r>
+              <a:rPr sz="2100" b="1">
+                <a:solidFill>
+                  <a:srgbClr val="202020"/>
+                </a:solidFill>
+              </a:rPr>
+              <a:t>This maps directly to Cotiviti's franchise</a:t>
+            </a:r>
+          </a:p>
+        </p:txBody>
+      </p:sp>
+      <p:sp>
+        <p:nvSpPr>
+          <p:cNvPr id="14" name="TextBox 13"/>
+          <p:cNvSpPr txBox="1"/>
+          <p:nvPr/>
+        </p:nvSpPr>
+        <p:spPr>
+          <a:xfrm>
+            <a:off x="1463040" y="5193791"/>
+            <a:ext cx="10058400" cy="822960"/>
+          </a:xfrm>
+          <a:prstGeom prst="rect">
+            <a:avLst/>
+          </a:prstGeom>
+          <a:noFill/>
+        </p:spPr>
+        <p:txBody>
+          <a:bodyPr wrap="square">
+            <a:spAutoFit/>
+          </a:bodyPr>
+          <a:lstStyle/>
+          <a:p>
+            <a:pPr algn="l"/>
+            <a:r>
+              <a:rPr sz="1600" b="0">
+                <a:solidFill>
+                  <a:srgbClr val="555555"/>
+                </a:solidFill>
+              </a:rPr>
+              <a:t>Chart-to-code for risk adjustment and payment integrity, with $31.7B/yr of improper payments in scope.</a:t>
+            </a:r>
+          </a:p>
+        </p:txBody>
+      </p:sp>
+    </p:spTree>
+  </p:cSld>
+  <p:clrMapOvr>
+    <a:masterClrMapping/>
+  </p:clrMapOvr>
+</p:sld>
+</file>
+
+<file path=ppt/slides/slide12.xml><?xml version="1.0" encoding="utf-8"?>
+<p:sld xmlns:a="http://schemas.openxmlformats.org/drawingml/2006/main" xmlns:p="http://schemas.openxmlformats.org/presentationml/2006/main" xmlns:r="http://schemas.openxmlformats.org/officeDocument/2006/relationships">
+  <p:cSld>
+    <p:bg>
+      <p:bgPr>
+        <a:solidFill>
           <a:srgbClr val="0E4D52"/>
         </a:solidFill>
         <a:effectLst/>
@@ -3634,8 +4147,8 @@
         </p:nvSpPr>
         <p:spPr>
           <a:xfrm>
-            <a:off x="731520" y="1828800"/>
-            <a:ext cx="4023360" cy="1828800"/>
+            <a:off x="731520" y="1600200"/>
+            <a:ext cx="4023360" cy="1280160"/>
           </a:xfrm>
           <a:prstGeom prst="rect">
             <a:avLst/>
@@ -3650,7 +4163,7 @@
           <a:p>
             <a:pPr algn="l"/>
             <a:r>
-              <a:rPr sz="9600" b="1">
+              <a:rPr sz="6600" b="1">
                 <a:solidFill>
                   <a:srgbClr val="189AA8"/>
                 </a:solidFill>
@@ -3668,8 +4181,8 @@
         </p:nvSpPr>
         <p:spPr>
           <a:xfrm>
-            <a:off x="777240" y="3566160"/>
-            <a:ext cx="4023360" cy="822960"/>
+            <a:off x="777240" y="2697480"/>
+            <a:ext cx="4206240" cy="640080"/>
           </a:xfrm>
           <a:prstGeom prst="rect">
             <a:avLst/>
@@ -3684,7 +4197,7 @@
           <a:p>
             <a:pPr algn="l"/>
             <a:r>
-              <a:rPr sz="1800" b="0">
+              <a:rPr sz="1700" b="0">
                 <a:solidFill>
                   <a:srgbClr val="555555"/>
                 </a:solidFill>
@@ -3702,8 +4215,76 @@
         </p:nvSpPr>
         <p:spPr>
           <a:xfrm>
-            <a:off x="5120640" y="2011680"/>
-            <a:ext cx="6400800" cy="4114800"/>
+            <a:off x="731520" y="3520440"/>
+            <a:ext cx="4206240" cy="1280160"/>
+          </a:xfrm>
+          <a:prstGeom prst="rect">
+            <a:avLst/>
+          </a:prstGeom>
+          <a:noFill/>
+        </p:spPr>
+        <p:txBody>
+          <a:bodyPr wrap="square">
+            <a:spAutoFit/>
+          </a:bodyPr>
+          <a:lstStyle/>
+          <a:p>
+            <a:pPr algn="l"/>
+            <a:r>
+              <a:rPr sz="6600" b="1">
+                <a:solidFill>
+                  <a:srgbClr val="0E4D52"/>
+                </a:solidFill>
+              </a:rPr>
+              <a:t>$31.7B</a:t>
+            </a:r>
+          </a:p>
+        </p:txBody>
+      </p:sp>
+      <p:sp>
+        <p:nvSpPr>
+          <p:cNvPr id="7" name="TextBox 6"/>
+          <p:cNvSpPr txBox="1"/>
+          <p:nvPr/>
+        </p:nvSpPr>
+        <p:spPr>
+          <a:xfrm>
+            <a:off x="777240" y="4617720"/>
+            <a:ext cx="4297680" cy="914400"/>
+          </a:xfrm>
+          <a:prstGeom prst="rect">
+            <a:avLst/>
+          </a:prstGeom>
+          <a:noFill/>
+        </p:spPr>
+        <p:txBody>
+          <a:bodyPr wrap="square">
+            <a:spAutoFit/>
+          </a:bodyPr>
+          <a:lstStyle/>
+          <a:p>
+            <a:pPr algn="l"/>
+            <a:r>
+              <a:rPr sz="1700" b="0">
+                <a:solidFill>
+                  <a:srgbClr val="555555"/>
+                </a:solidFill>
+              </a:rPr>
+              <a:t>Medicare FFS improper payments, FY2024 (CMS, 7.66%)</a:t>
+            </a:r>
+          </a:p>
+        </p:txBody>
+      </p:sp>
+      <p:sp>
+        <p:nvSpPr>
+          <p:cNvPr id="8" name="TextBox 7"/>
+          <p:cNvSpPr txBox="1"/>
+          <p:nvPr/>
+        </p:nvSpPr>
+        <p:spPr>
+          <a:xfrm>
+            <a:off x="5394960" y="2011680"/>
+            <a:ext cx="6126480" cy="4114800"/>
           </a:xfrm>
           <a:prstGeom prst="rect">
             <a:avLst/>
@@ -4106,7 +4687,7 @@
         <p:spPr>
           <a:xfrm>
             <a:off x="731520" y="1691640"/>
-            <a:ext cx="10698480" cy="4754880"/>
+            <a:ext cx="5852160" cy="4754880"/>
           </a:xfrm>
           <a:prstGeom prst="rect">
             <a:avLst/>
@@ -4125,12 +4706,12 @@
               </a:spcAft>
             </a:pPr>
             <a:r>
-              <a:rPr sz="2200" b="0">
+              <a:rPr sz="2000" b="0">
                 <a:solidFill>
                   <a:srgbClr val="202020"/>
                 </a:solidFill>
               </a:rPr>
-              <a:t>• Clinical Note Intelligence: free-text note → codeable ICD-10 / HCC findings.</a:t>
+              <a:t>• Free-text note → codeable ICD-10 / HCC findings.</a:t>
             </a:r>
           </a:p>
           <a:p>
@@ -4140,12 +4721,12 @@
               </a:spcAft>
             </a:pPr>
             <a:r>
-              <a:rPr sz="2200" b="0">
+              <a:rPr sz="2000" b="0">
                 <a:solidFill>
                   <a:srgbClr val="202020"/>
                 </a:solidFill>
               </a:rPr>
-              <a:t>• Every finding carries status, verbatim evidence, and calibrated confidence.</a:t>
+              <a:t>• Every finding carries status, verbatim evidence, and confidence.</a:t>
             </a:r>
           </a:p>
           <a:p>
@@ -4155,12 +4736,12 @@
               </a:spcAft>
             </a:pPr>
             <a:r>
-              <a:rPr sz="2200" b="0">
+              <a:rPr sz="2000" b="0">
                 <a:solidFill>
                   <a:srgbClr val="202020"/>
                 </a:solidFill>
               </a:rPr>
-              <a:t>• Schema-enforced JSON output — the API rejects malformed model responses.</a:t>
+              <a:t>• Schema-enforced JSON — malformed model output is rejected.</a:t>
             </a:r>
           </a:p>
           <a:p>
@@ -4170,12 +4751,12 @@
               </a:spcAft>
             </a:pPr>
             <a:r>
-              <a:rPr sz="2200" b="0">
+              <a:rPr sz="2000" b="0">
                 <a:solidFill>
                   <a:srgbClr val="202020"/>
                 </a:solidFill>
               </a:rPr>
-              <a:t>• Versioned prompts (YAML), 16 unit tests + CI, evaluation harness, Streamlit UI.</a:t>
+              <a:t>• Versioned prompts, 17 unit tests, ruff-linted CI, Streamlit UI.</a:t>
             </a:r>
           </a:p>
           <a:p>
@@ -4185,31 +4766,55 @@
               </a:spcAft>
             </a:pPr>
             <a:r>
-              <a:rPr sz="2200" b="0">
+              <a:rPr sz="2000" b="0">
                 <a:solidFill>
                   <a:srgbClr val="202020"/>
                 </a:solidFill>
               </a:rPr>
-              <a:t>• Validated live on real de-identified notes: hospital discharge summaries,</a:t>
-            </a:r>
-          </a:p>
-          <a:p>
-            <a:pPr lvl="1">
+              <a:t>• Validated live on real de-identified notes (discharge</a:t>
+            </a:r>
+          </a:p>
+          <a:p>
+            <a:pPr>
               <a:spcAft>
                 <a:spcPts val="800"/>
               </a:spcAft>
             </a:pPr>
             <a:r>
-              <a:rPr sz="1800" b="0">
-                <a:solidFill>
-                  <a:srgbClr val="555555"/>
-                </a:solidFill>
-              </a:rPr>
-              <a:t>– a comprehensive H&amp;P, and five MTSamples transcription notes.</a:t>
-            </a:r>
-          </a:p>
-        </p:txBody>
-      </p:sp>
+              <a:rPr sz="2000" b="0">
+                <a:solidFill>
+                  <a:srgbClr val="202020"/>
+                </a:solidFill>
+              </a:rPr>
+              <a:t>  summaries, an H&amp;P, five MTSamples transcriptions).</a:t>
+            </a:r>
+          </a:p>
+        </p:txBody>
+      </p:sp>
+      <p:pic>
+        <p:nvPicPr>
+          <p:cNvPr id="5" name="Picture 4" descr="architecture.png"/>
+          <p:cNvPicPr>
+            <a:picLocks noChangeAspect="1"/>
+          </p:cNvPicPr>
+          <p:nvPr/>
+        </p:nvPicPr>
+        <p:blipFill>
+          <a:blip r:embed="rId2"/>
+          <a:stretch>
+            <a:fillRect/>
+          </a:stretch>
+        </p:blipFill>
+        <p:spPr>
+          <a:xfrm>
+            <a:off x="6766560" y="1920240"/>
+            <a:ext cx="4846320" cy="2584704"/>
+          </a:xfrm>
+          <a:prstGeom prst="rect">
+            <a:avLst/>
+          </a:prstGeom>
+        </p:spPr>
+      </p:pic>
     </p:spTree>
   </p:cSld>
   <p:clrMapOvr>
@@ -6514,13 +7119,349 @@
       </p:sp>
       <p:sp>
         <p:nvSpPr>
-          <p:cNvPr id="4" name="TextBox 3"/>
+          <p:cNvPr id="4" name="Rectangle 3"/>
+          <p:cNvSpPr/>
+          <p:nvPr/>
+        </p:nvSpPr>
+        <p:spPr>
+          <a:xfrm>
+            <a:off x="731520" y="1783080"/>
+            <a:ext cx="3520440" cy="1737360"/>
+          </a:xfrm>
+          <a:prstGeom prst="rect">
+            <a:avLst/>
+          </a:prstGeom>
+          <a:solidFill>
+            <a:srgbClr val="F4F6F6"/>
+          </a:solidFill>
+          <a:ln>
+            <a:noFill/>
+          </a:ln>
+        </p:spPr>
+        <p:style>
+          <a:lnRef idx="1">
+            <a:schemeClr val="accent1"/>
+          </a:lnRef>
+          <a:fillRef idx="3">
+            <a:schemeClr val="accent1"/>
+          </a:fillRef>
+          <a:effectRef idx="2">
+            <a:schemeClr val="accent1"/>
+          </a:effectRef>
+          <a:fontRef idx="minor">
+            <a:schemeClr val="lt1"/>
+          </a:fontRef>
+        </p:style>
+        <p:txBody>
+          <a:bodyPr rtlCol="0" anchor="ctr"/>
+          <a:lstStyle/>
+          <a:p>
+            <a:pPr algn="ctr"/>
+          </a:p>
+        </p:txBody>
+      </p:sp>
+      <p:sp>
+        <p:nvSpPr>
+          <p:cNvPr id="5" name="TextBox 4"/>
           <p:cNvSpPr txBox="1"/>
           <p:nvPr/>
         </p:nvSpPr>
         <p:spPr>
           <a:xfrm>
-            <a:off x="731520" y="1691640"/>
+            <a:off x="731520" y="1920240"/>
+            <a:ext cx="3520440" cy="822960"/>
+          </a:xfrm>
+          <a:prstGeom prst="rect">
+            <a:avLst/>
+          </a:prstGeom>
+          <a:noFill/>
+        </p:spPr>
+        <p:txBody>
+          <a:bodyPr wrap="square">
+            <a:spAutoFit/>
+          </a:bodyPr>
+          <a:lstStyle/>
+          <a:p>
+            <a:pPr algn="ctr"/>
+            <a:r>
+              <a:rPr sz="4400" b="1">
+                <a:solidFill>
+                  <a:srgbClr val="0E4D52"/>
+                </a:solidFill>
+              </a:rPr>
+              <a:t>74,719</a:t>
+            </a:r>
+          </a:p>
+        </p:txBody>
+      </p:sp>
+      <p:sp>
+        <p:nvSpPr>
+          <p:cNvPr id="6" name="TextBox 5"/>
+          <p:cNvSpPr txBox="1"/>
+          <p:nvPr/>
+        </p:nvSpPr>
+        <p:spPr>
+          <a:xfrm>
+            <a:off x="868680" y="2743200"/>
+            <a:ext cx="3246120" cy="731520"/>
+          </a:xfrm>
+          <a:prstGeom prst="rect">
+            <a:avLst/>
+          </a:prstGeom>
+          <a:noFill/>
+        </p:spPr>
+        <p:txBody>
+          <a:bodyPr wrap="square">
+            <a:spAutoFit/>
+          </a:bodyPr>
+          <a:lstStyle/>
+          <a:p>
+            <a:pPr algn="ctr"/>
+            <a:r>
+              <a:rPr sz="1400" b="0">
+                <a:solidFill>
+                  <a:srgbClr val="555555"/>
+                </a:solidFill>
+              </a:rPr>
+              <a:t>official ICD-10-CM codes
+every emitted code checked</a:t>
+            </a:r>
+          </a:p>
+        </p:txBody>
+      </p:sp>
+      <p:sp>
+        <p:nvSpPr>
+          <p:cNvPr id="7" name="Rectangle 6"/>
+          <p:cNvSpPr/>
+          <p:nvPr/>
+        </p:nvSpPr>
+        <p:spPr>
+          <a:xfrm>
+            <a:off x="4526280" y="1783080"/>
+            <a:ext cx="3520440" cy="1737360"/>
+          </a:xfrm>
+          <a:prstGeom prst="rect">
+            <a:avLst/>
+          </a:prstGeom>
+          <a:solidFill>
+            <a:srgbClr val="F4F6F6"/>
+          </a:solidFill>
+          <a:ln>
+            <a:noFill/>
+          </a:ln>
+        </p:spPr>
+        <p:style>
+          <a:lnRef idx="1">
+            <a:schemeClr val="accent1"/>
+          </a:lnRef>
+          <a:fillRef idx="3">
+            <a:schemeClr val="accent1"/>
+          </a:fillRef>
+          <a:effectRef idx="2">
+            <a:schemeClr val="accent1"/>
+          </a:effectRef>
+          <a:fontRef idx="minor">
+            <a:schemeClr val="lt1"/>
+          </a:fontRef>
+        </p:style>
+        <p:txBody>
+          <a:bodyPr rtlCol="0" anchor="ctr"/>
+          <a:lstStyle/>
+          <a:p>
+            <a:pPr algn="ctr"/>
+          </a:p>
+        </p:txBody>
+      </p:sp>
+      <p:sp>
+        <p:nvSpPr>
+          <p:cNvPr id="8" name="TextBox 7"/>
+          <p:cNvSpPr txBox="1"/>
+          <p:nvPr/>
+        </p:nvSpPr>
+        <p:spPr>
+          <a:xfrm>
+            <a:off x="4526280" y="1920240"/>
+            <a:ext cx="3520440" cy="822960"/>
+          </a:xfrm>
+          <a:prstGeom prst="rect">
+            <a:avLst/>
+          </a:prstGeom>
+          <a:noFill/>
+        </p:spPr>
+        <p:txBody>
+          <a:bodyPr wrap="square">
+            <a:spAutoFit/>
+          </a:bodyPr>
+          <a:lstStyle/>
+          <a:p>
+            <a:pPr algn="ctr"/>
+            <a:r>
+              <a:rPr sz="4400" b="1">
+                <a:solidFill>
+                  <a:srgbClr val="008300"/>
+                </a:solidFill>
+              </a:rPr>
+              <a:t>97.8%</a:t>
+            </a:r>
+          </a:p>
+        </p:txBody>
+      </p:sp>
+      <p:sp>
+        <p:nvSpPr>
+          <p:cNvPr id="9" name="TextBox 8"/>
+          <p:cNvSpPr txBox="1"/>
+          <p:nvPr/>
+        </p:nvSpPr>
+        <p:spPr>
+          <a:xfrm>
+            <a:off x="4663440" y="2743200"/>
+            <a:ext cx="3246120" cy="731520"/>
+          </a:xfrm>
+          <a:prstGeom prst="rect">
+            <a:avLst/>
+          </a:prstGeom>
+          <a:noFill/>
+        </p:spPr>
+        <p:txBody>
+          <a:bodyPr wrap="square">
+            <a:spAutoFit/>
+          </a:bodyPr>
+          <a:lstStyle/>
+          <a:p>
+            <a:pPr algn="ctr"/>
+            <a:r>
+              <a:rPr sz="1400" b="0">
+                <a:solidFill>
+                  <a:srgbClr val="555555"/>
+                </a:solidFill>
+              </a:rPr>
+              <a:t>LLM codes valid
+across real-note runs</a:t>
+            </a:r>
+          </a:p>
+        </p:txBody>
+      </p:sp>
+      <p:sp>
+        <p:nvSpPr>
+          <p:cNvPr id="10" name="Rectangle 9"/>
+          <p:cNvSpPr/>
+          <p:nvPr/>
+        </p:nvSpPr>
+        <p:spPr>
+          <a:xfrm>
+            <a:off x="8321040" y="1783080"/>
+            <a:ext cx="3520440" cy="1737360"/>
+          </a:xfrm>
+          <a:prstGeom prst="rect">
+            <a:avLst/>
+          </a:prstGeom>
+          <a:solidFill>
+            <a:srgbClr val="F4F6F6"/>
+          </a:solidFill>
+          <a:ln>
+            <a:noFill/>
+          </a:ln>
+        </p:spPr>
+        <p:style>
+          <a:lnRef idx="1">
+            <a:schemeClr val="accent1"/>
+          </a:lnRef>
+          <a:fillRef idx="3">
+            <a:schemeClr val="accent1"/>
+          </a:fillRef>
+          <a:effectRef idx="2">
+            <a:schemeClr val="accent1"/>
+          </a:effectRef>
+          <a:fontRef idx="minor">
+            <a:schemeClr val="lt1"/>
+          </a:fontRef>
+        </p:style>
+        <p:txBody>
+          <a:bodyPr rtlCol="0" anchor="ctr"/>
+          <a:lstStyle/>
+          <a:p>
+            <a:pPr algn="ctr"/>
+          </a:p>
+        </p:txBody>
+      </p:sp>
+      <p:sp>
+        <p:nvSpPr>
+          <p:cNvPr id="11" name="TextBox 10"/>
+          <p:cNvSpPr txBox="1"/>
+          <p:nvPr/>
+        </p:nvSpPr>
+        <p:spPr>
+          <a:xfrm>
+            <a:off x="8321040" y="1920240"/>
+            <a:ext cx="3520440" cy="822960"/>
+          </a:xfrm>
+          <a:prstGeom prst="rect">
+            <a:avLst/>
+          </a:prstGeom>
+          <a:noFill/>
+        </p:spPr>
+        <p:txBody>
+          <a:bodyPr wrap="square">
+            <a:spAutoFit/>
+          </a:bodyPr>
+          <a:lstStyle/>
+          <a:p>
+            <a:pPr algn="ctr"/>
+            <a:r>
+              <a:rPr sz="4400" b="1">
+                <a:solidFill>
+                  <a:srgbClr val="189AA8"/>
+                </a:solidFill>
+              </a:rPr>
+              <a:t>92.1%</a:t>
+            </a:r>
+          </a:p>
+        </p:txBody>
+      </p:sp>
+      <p:sp>
+        <p:nvSpPr>
+          <p:cNvPr id="12" name="TextBox 11"/>
+          <p:cNvSpPr txBox="1"/>
+          <p:nvPr/>
+        </p:nvSpPr>
+        <p:spPr>
+          <a:xfrm>
+            <a:off x="8458200" y="2743200"/>
+            <a:ext cx="3246120" cy="731520"/>
+          </a:xfrm>
+          <a:prstGeom prst="rect">
+            <a:avLst/>
+          </a:prstGeom>
+          <a:noFill/>
+        </p:spPr>
+        <p:txBody>
+          <a:bodyPr wrap="square">
+            <a:spAutoFit/>
+          </a:bodyPr>
+          <a:lstStyle/>
+          <a:p>
+            <a:pPr algn="ctr"/>
+            <a:r>
+              <a:rPr sz="1400" b="0">
+                <a:solidFill>
+                  <a:srgbClr val="555555"/>
+                </a:solidFill>
+              </a:rPr>
+              <a:t>vision codes valid
+every miss flagged</a:t>
+            </a:r>
+          </a:p>
+        </p:txBody>
+      </p:sp>
+      <p:sp>
+        <p:nvSpPr>
+          <p:cNvPr id="13" name="TextBox 12"/>
+          <p:cNvSpPr txBox="1"/>
+          <p:nvPr/>
+        </p:nvSpPr>
+        <p:spPr>
+          <a:xfrm>
+            <a:off x="731520" y="3977639"/>
             <a:ext cx="10698480" cy="4754880"/>
           </a:xfrm>
           <a:prstGeom prst="rect">
@@ -6545,7 +7486,22 @@
                   <a:srgbClr val="202020"/>
                 </a:solidFill>
               </a:rPr>
-              <a:t>• Every emitted code checked against the official CMS ICD-10-CM set — 74,719 codes.</a:t>
+              <a:t>• Flagged live: R61.9, R21.9 — well-formed codes that don't exist.</a:t>
+            </a:r>
+          </a:p>
+          <a:p>
+            <a:pPr>
+              <a:spcAft>
+                <a:spcPts val="800"/>
+              </a:spcAft>
+            </a:pPr>
+            <a:r>
+              <a:rPr sz="2200" b="0">
+                <a:solidFill>
+                  <a:srgbClr val="202020"/>
+                </a:solidFill>
+              </a:rPr>
+              <a:t>• Code-set drift caught: M54.5, D59.1, C91.1 were valid in earlier fiscal</a:t>
             </a:r>
           </a:p>
           <a:p>
@@ -6560,7 +7516,7 @@
                   <a:srgbClr val="555555"/>
                 </a:solidFill>
               </a:rPr>
-              <a:t>– Caught live: the vision model emitted R61.9 and R21.9 — codes that don't exist.</a:t>
+              <a:t>– years, since subdivided — the model codes from its training era; the FY2026 table catches it.</a:t>
             </a:r>
           </a:p>
           <a:p>
@@ -6576,36 +7532,6 @@
                 </a:solidFill>
               </a:rPr>
               <a:t>• Every run writes an audit artifact: note, model, prompt version, findings + evidence.</a:t>
-            </a:r>
-          </a:p>
-          <a:p>
-            <a:pPr>
-              <a:spcAft>
-                <a:spcPts val="800"/>
-              </a:spcAft>
-            </a:pPr>
-            <a:r>
-              <a:rPr sz="2200" b="0">
-                <a:solidFill>
-                  <a:srgbClr val="202020"/>
-                </a:solidFill>
-              </a:rPr>
-              <a:t>• Structured-output schema, pydantic validation, retries and timeouts on every call.</a:t>
-            </a:r>
-          </a:p>
-          <a:p>
-            <a:pPr>
-              <a:spcAft>
-                <a:spcPts val="800"/>
-              </a:spcAft>
-            </a:pPr>
-            <a:r>
-              <a:rPr sz="2200" b="0">
-                <a:solidFill>
-                  <a:srgbClr val="202020"/>
-                </a:solidFill>
-              </a:rPr>
-              <a:t>• This is the report's recommended architecture for Cotiviti — in miniature.</a:t>
             </a:r>
           </a:p>
         </p:txBody>

</xml_diff>

<commit_message>
Fix: pass configured temperature to API calls; complete gold set to 11 conditions
- temperature: 0.0 was declared in prompts/v1.yaml but never sent to the
  API — every call ran at default temperature, causing run-to-run variance.
  Now passed in both text and vision extractors.
- Gold set v2: the LLM repeatedly surfaced two findings verbatim in the
  notes (lower-extremity edema, fatigue) that the original labels omitted —
  both now labeled. Rules recall drops to 0.82 (they miss both); LLM 1.00.
- BENCHMARKS, DECISIONS, slides updated to the corrected numbers.
</commit_message>
<xml_diff>
--- a/deliverables/slides.pptx
+++ b/deliverables/slides.pptx
@@ -4921,7 +4921,7 @@
                   <a:srgbClr val="189AA8"/>
                 </a:solidFill>
               </a:rPr>
-              <a:t>cni eval · 9 conditions across 2 notes · live claude-haiku-4-5</a:t>
+              <a:t>cni eval · 11 conditions across 2 notes · live claude-haiku-4-5, temperature 0</a:t>
             </a:r>
           </a:p>
         </p:txBody>
@@ -5112,7 +5112,7 @@
                             <a:srgbClr val="202020"/>
                           </a:solidFill>
                         </a:rPr>
-                        <a:t>1.00</a:t>
+                        <a:t>0.82</a:t>
                       </a:r>
                     </a:p>
                   </a:txBody>
@@ -5133,7 +5133,7 @@
                             <a:srgbClr val="202020"/>
                           </a:solidFill>
                         </a:rPr>
-                        <a:t>1.00</a:t>
+                        <a:t>0.90</a:t>
                       </a:r>
                     </a:p>
                   </a:txBody>
@@ -5565,7 +5565,7 @@
                   <a:srgbClr val="202020"/>
                 </a:solidFill>
               </a:rPr>
-              <a:t>The note says hypertension is "suspected, not yet confirmed."</a:t>
+              <a:t>Recall: rules miss edema and fatigue outright — terms outside the dictionary.</a:t>
             </a:r>
           </a:p>
           <a:p>
@@ -5580,7 +5580,7 @@
                   <a:srgbClr val="202020"/>
                 </a:solidFill>
               </a:rPr>
-              <a:t>Rules code it ACTIVE (backward-only negation scan). The LLM reads</a:t>
+              <a:t>Status: the note says hypertension is "suspected, not yet confirmed" —</a:t>
             </a:r>
           </a:p>
           <a:p>
@@ -5595,7 +5595,7 @@
                   <a:srgbClr val="202020"/>
                 </a:solidFill>
               </a:rPr>
-              <a:t>the sentence and says UNCERTAIN — the 89% → 100% gap is exactly that.</a:t>
+              <a:t>rules code it ACTIVE (backward-only negation scan); the LLM says UNCERTAIN.</a:t>
             </a:r>
           </a:p>
         </p:txBody>

</xml_diff>